<commit_message>
docs: address commission review of thesis and defense materials
</commit_message>
<xml_diff>
--- a/presentation/defense.pptx
+++ b/presentation/defense.pptx
@@ -2,44 +2,44 @@
 <file path=ppt/presentation.xml><?xml version="1.0" encoding="utf-8"?>
 <p:presentation xmlns:p="http://schemas.openxmlformats.org/presentationml/2006/main" embedTrueTypeFonts="1" saveSubsetFonts="1">
   <p:sldMasterIdLst>
-    <p:sldMasterId xmlns:r="http://schemas.openxmlformats.org/officeDocument/2006/relationships" id="2147483648" r:id="R29eb8ab093594375"/>
+    <p:sldMasterId xmlns:r="http://schemas.openxmlformats.org/officeDocument/2006/relationships" id="2147483648" r:id="R1ff4d0298f2b4ae4"/>
   </p:sldMasterIdLst>
   <p:notesMasterIdLst>
-    <p:notesMasterId xmlns:r="http://schemas.openxmlformats.org/officeDocument/2006/relationships" r:id="R1688011a48094975"/>
+    <p:notesMasterId xmlns:r="http://schemas.openxmlformats.org/officeDocument/2006/relationships" r:id="R1bec61b3359e4bcf"/>
   </p:notesMasterIdLst>
   <p:sldIdLst>
-    <p:sldId xmlns:r="http://schemas.openxmlformats.org/officeDocument/2006/relationships" id="256" r:id="Rb135a04dc8c94468"/>
-    <p:sldId xmlns:r="http://schemas.openxmlformats.org/officeDocument/2006/relationships" id="257" r:id="Rf6e3161573de4b83"/>
-    <p:sldId xmlns:r="http://schemas.openxmlformats.org/officeDocument/2006/relationships" id="258" r:id="Reb85f06ae7f1448d"/>
-    <p:sldId xmlns:r="http://schemas.openxmlformats.org/officeDocument/2006/relationships" id="259" r:id="R2120be0c06c24b33"/>
-    <p:sldId xmlns:r="http://schemas.openxmlformats.org/officeDocument/2006/relationships" id="260" r:id="R4b5a02de3a1147a8"/>
-    <p:sldId xmlns:r="http://schemas.openxmlformats.org/officeDocument/2006/relationships" id="261" r:id="Ra7c5e7f504864146"/>
-    <p:sldId xmlns:r="http://schemas.openxmlformats.org/officeDocument/2006/relationships" id="262" r:id="Ra6720e46b53c4694"/>
-    <p:sldId xmlns:r="http://schemas.openxmlformats.org/officeDocument/2006/relationships" id="263" r:id="Rbbd20f9a44134c85"/>
-    <p:sldId xmlns:r="http://schemas.openxmlformats.org/officeDocument/2006/relationships" id="264" r:id="Re567ed2cd0fe4927"/>
-    <p:sldId xmlns:r="http://schemas.openxmlformats.org/officeDocument/2006/relationships" id="265" r:id="R4648617846974d80"/>
-    <p:sldId xmlns:r="http://schemas.openxmlformats.org/officeDocument/2006/relationships" id="266" r:id="Rd1ed6fce7e7040b2"/>
-    <p:sldId xmlns:r="http://schemas.openxmlformats.org/officeDocument/2006/relationships" id="267" r:id="Rd23742d30eca4c03"/>
-    <p:sldId xmlns:r="http://schemas.openxmlformats.org/officeDocument/2006/relationships" id="268" r:id="R71aa97c8c75d4adb"/>
-    <p:sldId xmlns:r="http://schemas.openxmlformats.org/officeDocument/2006/relationships" id="269" r:id="Ref24fa2ad1104ae7"/>
+    <p:sldId xmlns:r="http://schemas.openxmlformats.org/officeDocument/2006/relationships" id="256" r:id="R7ccc777832b44015"/>
+    <p:sldId xmlns:r="http://schemas.openxmlformats.org/officeDocument/2006/relationships" id="257" r:id="R9d186c5a62e448b0"/>
+    <p:sldId xmlns:r="http://schemas.openxmlformats.org/officeDocument/2006/relationships" id="258" r:id="R68c6fa1ea3aa4ce3"/>
+    <p:sldId xmlns:r="http://schemas.openxmlformats.org/officeDocument/2006/relationships" id="259" r:id="R62433fd84b7949a7"/>
+    <p:sldId xmlns:r="http://schemas.openxmlformats.org/officeDocument/2006/relationships" id="260" r:id="R6b547299a0af4dee"/>
+    <p:sldId xmlns:r="http://schemas.openxmlformats.org/officeDocument/2006/relationships" id="261" r:id="Rfa45d302d5fc4fec"/>
+    <p:sldId xmlns:r="http://schemas.openxmlformats.org/officeDocument/2006/relationships" id="262" r:id="Ra912db8b65574a62"/>
+    <p:sldId xmlns:r="http://schemas.openxmlformats.org/officeDocument/2006/relationships" id="263" r:id="Raac2a8d5562d4b2f"/>
+    <p:sldId xmlns:r="http://schemas.openxmlformats.org/officeDocument/2006/relationships" id="264" r:id="R8948cfd60e5c4365"/>
+    <p:sldId xmlns:r="http://schemas.openxmlformats.org/officeDocument/2006/relationships" id="265" r:id="Rd082aec9079743b6"/>
+    <p:sldId xmlns:r="http://schemas.openxmlformats.org/officeDocument/2006/relationships" id="266" r:id="Ra7f6dae11ba847c2"/>
+    <p:sldId xmlns:r="http://schemas.openxmlformats.org/officeDocument/2006/relationships" id="267" r:id="Rb1c29da8f1344b07"/>
+    <p:sldId xmlns:r="http://schemas.openxmlformats.org/officeDocument/2006/relationships" id="268" r:id="R6ec660b8c7fd405c"/>
+    <p:sldId xmlns:r="http://schemas.openxmlformats.org/officeDocument/2006/relationships" id="269" r:id="R0f9aab90aaaa455e"/>
   </p:sldIdLst>
   <p:sldSz cx="12192000" cy="6858000"/>
   <p:notesSz cx="6858000" cy="9144000"/>
   <p:embeddedFontLst>
     <p:embeddedFont>
       <p:font typeface="ALS Sector Bold"/>
-      <p:bold xmlns:r="http://schemas.openxmlformats.org/officeDocument/2006/relationships" r:id="R1e43be1bab224ccf"/>
+      <p:bold xmlns:r="http://schemas.openxmlformats.org/officeDocument/2006/relationships" r:id="R4e96a50fc63441a5"/>
     </p:embeddedFont>
     <p:embeddedFont>
       <p:font typeface="ALS Sector Regular"/>
-      <p:regular xmlns:r="http://schemas.openxmlformats.org/officeDocument/2006/relationships" r:id="Rb601c0c0b3c64140"/>
+      <p:regular xmlns:r="http://schemas.openxmlformats.org/officeDocument/2006/relationships" r:id="R679288ff7b0f4f54"/>
     </p:embeddedFont>
     <p:embeddedFont>
       <p:font typeface="Open Sans"/>
-      <p:regular xmlns:r="http://schemas.openxmlformats.org/officeDocument/2006/relationships" r:id="R818f20a33ef04572"/>
-      <p:bold xmlns:r="http://schemas.openxmlformats.org/officeDocument/2006/relationships" r:id="R6fc1082e019640a7"/>
-      <p:italic xmlns:r="http://schemas.openxmlformats.org/officeDocument/2006/relationships" r:id="R3bc575c438a74236"/>
-      <p:boldItalic xmlns:r="http://schemas.openxmlformats.org/officeDocument/2006/relationships" r:id="R45ed50016a77451d"/>
+      <p:regular xmlns:r="http://schemas.openxmlformats.org/officeDocument/2006/relationships" r:id="Rd03f28e2982e4c16"/>
+      <p:bold xmlns:r="http://schemas.openxmlformats.org/officeDocument/2006/relationships" r:id="R20aef2a743bd4347"/>
+      <p:italic xmlns:r="http://schemas.openxmlformats.org/officeDocument/2006/relationships" r:id="R6c8e33d450d541c5"/>
+      <p:boldItalic xmlns:r="http://schemas.openxmlformats.org/officeDocument/2006/relationships" r:id="R8c6b02192bd243d5"/>
     </p:embeddedFont>
   </p:embeddedFontLst>
 </p:presentation>
@@ -1499,7 +1499,7 @@
           <p:nvPr/>
         </p:nvPicPr>
         <p:blipFill rotWithShape="1">
-          <a:blip xmlns:r="http://schemas.openxmlformats.org/officeDocument/2006/relationships" xmlns:a="http://schemas.openxmlformats.org/drawingml/2006/main" r:embed="Rfc0d1589c51b4345">
+          <a:blip xmlns:r="http://schemas.openxmlformats.org/officeDocument/2006/relationships" xmlns:a="http://schemas.openxmlformats.org/drawingml/2006/main" r:embed="R1ce8bbd502fe4bf7">
             <a:alphaModFix/>
           </a:blip>
           <a:srcRect xmlns:a="http://schemas.openxmlformats.org/drawingml/2006/main" l="0" t="16270" r="0" b="8845"/>
@@ -1527,7 +1527,7 @@
           <p:nvPr/>
         </p:nvPicPr>
         <p:blipFill rotWithShape="1">
-          <a:blip xmlns:r="http://schemas.openxmlformats.org/officeDocument/2006/relationships" xmlns:a="http://schemas.openxmlformats.org/drawingml/2006/main" r:embed="R835f7e1c0894479c">
+          <a:blip xmlns:r="http://schemas.openxmlformats.org/officeDocument/2006/relationships" xmlns:a="http://schemas.openxmlformats.org/drawingml/2006/main" r:embed="Rdb9dba23ca094db2">
             <a:alphaModFix/>
           </a:blip>
           <a:srcRect xmlns:a="http://schemas.openxmlformats.org/drawingml/2006/main" l="0" t="0" r="0" b="0"/>
@@ -1611,7 +1611,7 @@
           <p:nvPr/>
         </p:nvPicPr>
         <p:blipFill>
-          <a:blip xmlns:r="http://schemas.openxmlformats.org/officeDocument/2006/relationships" xmlns:a="http://schemas.openxmlformats.org/drawingml/2006/main" r:embed="R6dffbd057dbe4b69"/>
+          <a:blip xmlns:r="http://schemas.openxmlformats.org/officeDocument/2006/relationships" xmlns:a="http://schemas.openxmlformats.org/drawingml/2006/main" r:embed="R470e211e6a15448f"/>
           <a:stretch xmlns:a="http://schemas.openxmlformats.org/drawingml/2006/main">
             <a:fillRect l="0" t="0" r="0" b="0"/>
           </a:stretch>
@@ -1997,7 +1997,7 @@
           <p:cNvPr id="28" name="Google Shape;28;p8">
             <a:extLst xmlns:a="http://schemas.openxmlformats.org/drawingml/2006/main">
               <a:ext uri="{FF2B5EF4-FFF2-40B4-BE49-F238E27FC236}">
-                <a16:creationId xmlns:a16="http://schemas.microsoft.com/office/drawing/2014/main" id="{486F36CF-D04B-4916-92E4-285CB5A0AAE1}"/>
+                <a16:creationId xmlns:a16="http://schemas.microsoft.com/office/drawing/2014/main" id="{21017031-ACA1-45E7-82CA-9E4E15319455}"/>
               </a:ext>
             </a:extLst>
           </p:cNvPr>
@@ -2213,7 +2213,7 @@
           <p:cNvPr id="30" name="Google Shape;30;p8">
             <a:extLst xmlns:a="http://schemas.openxmlformats.org/drawingml/2006/main">
               <a:ext uri="{FF2B5EF4-FFF2-40B4-BE49-F238E27FC236}">
-                <a16:creationId xmlns:a16="http://schemas.microsoft.com/office/drawing/2014/main" id="{4A80622C-1D6C-437B-AF74-2F79046A3F33}"/>
+                <a16:creationId xmlns:a16="http://schemas.microsoft.com/office/drawing/2014/main" id="{D2F62B0E-E026-4263-931B-98373134FF66}"/>
               </a:ext>
             </a:extLst>
           </p:cNvPr>
@@ -3550,7 +3550,7 @@
           <p:cNvPr id="81" name="Google Shape;81;p17">
             <a:extLst xmlns:a="http://schemas.openxmlformats.org/drawingml/2006/main">
               <a:ext uri="{FF2B5EF4-FFF2-40B4-BE49-F238E27FC236}">
-                <a16:creationId xmlns:a16="http://schemas.microsoft.com/office/drawing/2014/main" id="{629BA0FE-54DA-4294-B0EB-77983DC9FCDF}"/>
+                <a16:creationId xmlns:a16="http://schemas.microsoft.com/office/drawing/2014/main" id="{3D8DCB02-3047-4876-BE1E-88A14BD43230}"/>
               </a:ext>
             </a:extLst>
           </p:cNvPr>
@@ -3766,7 +3766,7 @@
           <p:cNvPr id="82" name="Google Shape;82;p17">
             <a:extLst xmlns:a="http://schemas.openxmlformats.org/drawingml/2006/main">
               <a:ext uri="{FF2B5EF4-FFF2-40B4-BE49-F238E27FC236}">
-                <a16:creationId xmlns:a16="http://schemas.microsoft.com/office/drawing/2014/main" id="{413456E9-1B36-4019-B4AA-19153DAA8DAF}"/>
+                <a16:creationId xmlns:a16="http://schemas.microsoft.com/office/drawing/2014/main" id="{5FBFF319-9DEF-4539-A786-BCB682D40299}"/>
               </a:ext>
             </a:extLst>
           </p:cNvPr>
@@ -3987,7 +3987,7 @@
           <p:cNvPr id="83" name="Google Shape;83;p17">
             <a:extLst xmlns:a="http://schemas.openxmlformats.org/drawingml/2006/main">
               <a:ext uri="{FF2B5EF4-FFF2-40B4-BE49-F238E27FC236}">
-                <a16:creationId xmlns:a16="http://schemas.microsoft.com/office/drawing/2014/main" id="{B010F907-7B6F-42A8-A236-EBEB2BCDEA5E}"/>
+                <a16:creationId xmlns:a16="http://schemas.microsoft.com/office/drawing/2014/main" id="{C8DB72E5-DEC2-4461-96D5-8BDE2E148522}"/>
               </a:ext>
             </a:extLst>
           </p:cNvPr>
@@ -4119,7 +4119,7 @@
           <p:cNvPr id="75" name="Google Shape;75;p16">
             <a:extLst xmlns:a="http://schemas.openxmlformats.org/drawingml/2006/main">
               <a:ext uri="{FF2B5EF4-FFF2-40B4-BE49-F238E27FC236}">
-                <a16:creationId xmlns:a16="http://schemas.microsoft.com/office/drawing/2014/main" id="{101564C5-6336-4004-A9DD-34AE686B295D}"/>
+                <a16:creationId xmlns:a16="http://schemas.microsoft.com/office/drawing/2014/main" id="{77AC5F5A-89EF-4F1F-A09C-B37D2F15FE03}"/>
               </a:ext>
             </a:extLst>
           </p:cNvPr>
@@ -4273,7 +4273,7 @@
           <p:cNvPr id="76" name="Google Shape;76;p16">
             <a:extLst xmlns:a="http://schemas.openxmlformats.org/drawingml/2006/main">
               <a:ext uri="{FF2B5EF4-FFF2-40B4-BE49-F238E27FC236}">
-                <a16:creationId xmlns:a16="http://schemas.microsoft.com/office/drawing/2014/main" id="{31AEF09C-BF8F-40C8-9975-121629853398}"/>
+                <a16:creationId xmlns:a16="http://schemas.microsoft.com/office/drawing/2014/main" id="{B508D498-D12C-4572-922B-EE0FB305D730}"/>
               </a:ext>
             </a:extLst>
           </p:cNvPr>
@@ -4473,7 +4473,7 @@
           <p:cNvPr id="77" name="Google Shape;77;p16">
             <a:extLst xmlns:a="http://schemas.openxmlformats.org/drawingml/2006/main">
               <a:ext uri="{FF2B5EF4-FFF2-40B4-BE49-F238E27FC236}">
-                <a16:creationId xmlns:a16="http://schemas.microsoft.com/office/drawing/2014/main" id="{9F3D10BB-BDB8-4C25-88C7-4AC232863D01}"/>
+                <a16:creationId xmlns:a16="http://schemas.microsoft.com/office/drawing/2014/main" id="{15668112-AD50-4C2A-AD70-0712A66BDF4D}"/>
               </a:ext>
             </a:extLst>
           </p:cNvPr>
@@ -4826,7 +4826,7 @@
           <p:cNvPr id="85" name="Google Shape;85;p18">
             <a:extLst xmlns:a="http://schemas.openxmlformats.org/drawingml/2006/main">
               <a:ext uri="{FF2B5EF4-FFF2-40B4-BE49-F238E27FC236}">
-                <a16:creationId xmlns:a16="http://schemas.microsoft.com/office/drawing/2014/main" id="{44836EB0-11E5-4320-A5D2-A1E50DFD7B42}"/>
+                <a16:creationId xmlns:a16="http://schemas.microsoft.com/office/drawing/2014/main" id="{0EBF7065-4526-41C3-901D-B14C3DFF0530}"/>
               </a:ext>
             </a:extLst>
           </p:cNvPr>
@@ -4980,7 +4980,7 @@
           <p:cNvPr id="86" name="Google Shape;86;p18">
             <a:extLst xmlns:a="http://schemas.openxmlformats.org/drawingml/2006/main">
               <a:ext uri="{FF2B5EF4-FFF2-40B4-BE49-F238E27FC236}">
-                <a16:creationId xmlns:a16="http://schemas.microsoft.com/office/drawing/2014/main" id="{F39F9092-2118-4A2F-8CDE-54DFBCCC12CD}"/>
+                <a16:creationId xmlns:a16="http://schemas.microsoft.com/office/drawing/2014/main" id="{4EFD207F-A49B-4EC8-8619-5C62E36BEDAA}"/>
               </a:ext>
             </a:extLst>
           </p:cNvPr>
@@ -5037,7 +5037,7 @@
           <p:cNvPr id="87" name="Google Shape;87;p18">
             <a:extLst xmlns:a="http://schemas.openxmlformats.org/drawingml/2006/main">
               <a:ext uri="{FF2B5EF4-FFF2-40B4-BE49-F238E27FC236}">
-                <a16:creationId xmlns:a16="http://schemas.microsoft.com/office/drawing/2014/main" id="{C6E81324-F34E-41ED-BC9D-03CD52252BD8}"/>
+                <a16:creationId xmlns:a16="http://schemas.microsoft.com/office/drawing/2014/main" id="{ED2CEF75-B079-4092-A0F3-4044263E5D8D}"/>
               </a:ext>
             </a:extLst>
           </p:cNvPr>
@@ -5394,7 +5394,7 @@
           <p:nvPr/>
         </p:nvPicPr>
         <p:blipFill rotWithShape="1">
-          <a:blip xmlns:r="http://schemas.openxmlformats.org/officeDocument/2006/relationships" xmlns:a="http://schemas.openxmlformats.org/drawingml/2006/main" r:embed="Rf950aa5dea944c18">
+          <a:blip xmlns:r="http://schemas.openxmlformats.org/officeDocument/2006/relationships" xmlns:a="http://schemas.openxmlformats.org/drawingml/2006/main" r:embed="Rc3483a88cd2b43c1">
             <a:alphaModFix/>
           </a:blip>
           <a:srcRect xmlns:a="http://schemas.openxmlformats.org/drawingml/2006/main" l="0" t="16270" r="0" b="8845"/>
@@ -5422,7 +5422,7 @@
           <p:nvPr/>
         </p:nvPicPr>
         <p:blipFill>
-          <a:blip xmlns:r="http://schemas.openxmlformats.org/officeDocument/2006/relationships" xmlns:a="http://schemas.openxmlformats.org/drawingml/2006/main" r:embed="Rfef6035aebaf4dc2"/>
+          <a:blip xmlns:r="http://schemas.openxmlformats.org/officeDocument/2006/relationships" xmlns:a="http://schemas.openxmlformats.org/drawingml/2006/main" r:embed="R5f61474938a84e9e"/>
           <a:stretch xmlns:a="http://schemas.openxmlformats.org/drawingml/2006/main">
             <a:fillRect l="0" t="0" r="0" b="0"/>
           </a:stretch>
@@ -5446,7 +5446,7 @@
           <p:nvPr/>
         </p:nvPicPr>
         <p:blipFill>
-          <a:blip xmlns:r="http://schemas.openxmlformats.org/officeDocument/2006/relationships" xmlns:a="http://schemas.openxmlformats.org/drawingml/2006/main" r:embed="R413706504207405f"/>
+          <a:blip xmlns:r="http://schemas.openxmlformats.org/officeDocument/2006/relationships" xmlns:a="http://schemas.openxmlformats.org/drawingml/2006/main" r:embed="R4d6b771c29d34e1e"/>
           <a:stretch xmlns:a="http://schemas.openxmlformats.org/drawingml/2006/main">
             <a:fillRect l="0" t="0" r="0" b="0"/>
           </a:stretch>
@@ -5679,7 +5679,7 @@
           <p:nvPr/>
         </p:nvPicPr>
         <p:blipFill>
-          <a:blip xmlns:r="http://schemas.openxmlformats.org/officeDocument/2006/relationships" xmlns:a="http://schemas.openxmlformats.org/drawingml/2006/main" r:embed="R6f91d0b4fba14300"/>
+          <a:blip xmlns:r="http://schemas.openxmlformats.org/officeDocument/2006/relationships" xmlns:a="http://schemas.openxmlformats.org/drawingml/2006/main" r:embed="R359627b02f854cb2"/>
           <a:stretch xmlns:a="http://schemas.openxmlformats.org/drawingml/2006/main">
             <a:fillRect l="0" t="0" r="0" b="0"/>
           </a:stretch>
@@ -5699,7 +5699,7 @@
           <p:cNvPr id="7" name="Google Shape;7;p4">
             <a:extLst xmlns:a="http://schemas.openxmlformats.org/drawingml/2006/main">
               <a:ext uri="{FF2B5EF4-FFF2-40B4-BE49-F238E27FC236}">
-                <a16:creationId xmlns:a16="http://schemas.microsoft.com/office/drawing/2014/main" id="{A131C054-64D5-43E6-BEB9-84198D4B45DD}"/>
+                <a16:creationId xmlns:a16="http://schemas.microsoft.com/office/drawing/2014/main" id="{7DC10A39-E55E-42A3-84DF-AD748E379C29}"/>
               </a:ext>
             </a:extLst>
           </p:cNvPr>
@@ -5974,7 +5974,7 @@
           <p:cNvPr id="8" name="Google Shape;8;p4">
             <a:extLst xmlns:a="http://schemas.openxmlformats.org/drawingml/2006/main">
               <a:ext uri="{FF2B5EF4-FFF2-40B4-BE49-F238E27FC236}">
-                <a16:creationId xmlns:a16="http://schemas.microsoft.com/office/drawing/2014/main" id="{A2DA34F2-2F02-45E9-9E9B-E9F729B6708E}"/>
+                <a16:creationId xmlns:a16="http://schemas.microsoft.com/office/drawing/2014/main" id="{F2ED3865-3D69-4003-A9D8-FAB452F1A971}"/>
               </a:ext>
             </a:extLst>
           </p:cNvPr>
@@ -6142,15 +6142,15 @@
   </p:cSld>
   <p:clrMap bg1="lt1" tx1="dk1" bg2="dk2" tx2="lt2" accent1="accent1" accent2="accent2" accent3="accent3" accent4="accent4" accent5="accent5" accent6="accent6" hlink="hlink" folHlink="folHlink"/>
   <p:sldLayoutIdLst>
-    <p:sldLayoutId xmlns:r="http://schemas.openxmlformats.org/officeDocument/2006/relationships" id="2147483649" r:id="R1af83a1cfd6448af"/>
-    <p:sldLayoutId xmlns:r="http://schemas.openxmlformats.org/officeDocument/2006/relationships" id="2147483650" r:id="Rc9cb4d37a5344a1c"/>
-    <p:sldLayoutId xmlns:r="http://schemas.openxmlformats.org/officeDocument/2006/relationships" id="2147483651" r:id="Re9b6849528f24a32"/>
-    <p:sldLayoutId xmlns:r="http://schemas.openxmlformats.org/officeDocument/2006/relationships" id="2147483652" r:id="R5803ebd195c847a3"/>
-    <p:sldLayoutId xmlns:r="http://schemas.openxmlformats.org/officeDocument/2006/relationships" id="2147483653" r:id="R9f09bb46ca7d4840"/>
-    <p:sldLayoutId xmlns:r="http://schemas.openxmlformats.org/officeDocument/2006/relationships" id="2147483654" r:id="Rfa052786a9274351"/>
-    <p:sldLayoutId xmlns:r="http://schemas.openxmlformats.org/officeDocument/2006/relationships" id="2147483655" r:id="R0f0a8d9241af490e"/>
-    <p:sldLayoutId xmlns:r="http://schemas.openxmlformats.org/officeDocument/2006/relationships" id="2147483656" r:id="Rf16a402e6e454600"/>
-    <p:sldLayoutId xmlns:r="http://schemas.openxmlformats.org/officeDocument/2006/relationships" id="2147483657" r:id="Rd34919630dae4b0d"/>
+    <p:sldLayoutId xmlns:r="http://schemas.openxmlformats.org/officeDocument/2006/relationships" id="2147483649" r:id="R02aeb8bdc1774acb"/>
+    <p:sldLayoutId xmlns:r="http://schemas.openxmlformats.org/officeDocument/2006/relationships" id="2147483650" r:id="R9a46be0eb78c4361"/>
+    <p:sldLayoutId xmlns:r="http://schemas.openxmlformats.org/officeDocument/2006/relationships" id="2147483651" r:id="Rafc2f95c219d495d"/>
+    <p:sldLayoutId xmlns:r="http://schemas.openxmlformats.org/officeDocument/2006/relationships" id="2147483652" r:id="Ref4b7e4ab8a74d09"/>
+    <p:sldLayoutId xmlns:r="http://schemas.openxmlformats.org/officeDocument/2006/relationships" id="2147483653" r:id="Rdee3622811bd4d6c"/>
+    <p:sldLayoutId xmlns:r="http://schemas.openxmlformats.org/officeDocument/2006/relationships" id="2147483654" r:id="Re9ddf53d1dd14a2c"/>
+    <p:sldLayoutId xmlns:r="http://schemas.openxmlformats.org/officeDocument/2006/relationships" id="2147483655" r:id="R1f72abe75e934852"/>
+    <p:sldLayoutId xmlns:r="http://schemas.openxmlformats.org/officeDocument/2006/relationships" id="2147483656" r:id="R7d6277374cbc4028"/>
+    <p:sldLayoutId xmlns:r="http://schemas.openxmlformats.org/officeDocument/2006/relationships" id="2147483657" r:id="R49945d89e649487e"/>
   </p:sldLayoutIdLst>
   <p:hf hdr="0" ftr="0" dt="0"/>
   <p:txStyles>
@@ -7059,7 +7059,7 @@
                 <a:ea typeface="+mj-lt"/>
                 <a:cs typeface="+mj-lt"/>
               </a:rPr>
-              <a:t>Прогнозирование конечных свойств композиционных материалов</a:t>
+              <a:t>Прогнозирование конечных свойств новых материалов (композиционных материалов)</a:t>
             </a:r>
           </a:p>
         </p:txBody>
@@ -7109,7 +7109,7 @@
     </p:spTree>
     <p:extLst>
       <p:ext uri="{BB962C8B-B14F-4D97-AF65-F5344CB8AC3E}">
-        <p14:creationId xmlns:p14="http://schemas.microsoft.com/office/powerpoint/2010/main" val="1726806680"/>
+        <p14:creationId xmlns:p14="http://schemas.microsoft.com/office/powerpoint/2010/main" val="1250173103"/>
       </p:ext>
     </p:extLst>
   </p:cSld>
@@ -7117,7 +7117,7 @@
 </file>
 
 <file path=ppt/slides/slide10.xml><?xml version="1.0" encoding="utf-8"?>
-<p:sld xmlns:p="http://schemas.openxmlformats.org/presentationml/2006/main" showMasterSp="0">
+<p:sld xmlns:p="http://schemas.openxmlformats.org/presentationml/2006/main">
   <p:cSld>
     <p:spTree>
       <p:nvGrpSpPr>
@@ -7133,7 +7133,7 @@
           <p:cNvPr id="6" name="">
             <a:extLst xmlns:a="http://schemas.openxmlformats.org/drawingml/2006/main">
               <a:ext uri="{FF2B5EF4-FFF2-40B4-BE49-F238E27FC236}">
-                <a16:creationId xmlns:a16="http://schemas.microsoft.com/office/drawing/2014/main" id="{FB97FC97-A2F9-4A00-8EEB-1C31C8BF3B05}"/>
+                <a16:creationId xmlns:a16="http://schemas.microsoft.com/office/drawing/2014/main" id="{43FBBED3-F9CB-4DD8-B28B-155762D0A762}"/>
               </a:ext>
             </a:extLst>
           </p:cNvPr>
@@ -7166,7 +7166,7 @@
           <p:cNvPr id="2" name="">
             <a:extLst xmlns:a="http://schemas.openxmlformats.org/drawingml/2006/main">
               <a:ext uri="{FF2B5EF4-FFF2-40B4-BE49-F238E27FC236}">
-                <a16:creationId xmlns:a16="http://schemas.microsoft.com/office/drawing/2014/main" id="{E022D03F-6A5C-4426-B433-C6F92966C624}"/>
+                <a16:creationId xmlns:a16="http://schemas.microsoft.com/office/drawing/2014/main" id="{2E04DA86-F6C6-41F0-A9ED-45E7C4174C77}"/>
               </a:ext>
             </a:extLst>
           </p:cNvPr>
@@ -7206,7 +7206,7 @@
                   <a:srgbClr val="065CAB"/>
                 </a:solidFill>
               </a:rPr>
-              <a:t>Test: прочность</a:t>
+              <a:t>Отложенная оценка: прочность</a:t>
             </a:r>
           </a:p>
         </p:txBody>
@@ -7216,7 +7216,7 @@
           <p:cNvPr id="3" name="">
             <a:extLst xmlns:a="http://schemas.openxmlformats.org/drawingml/2006/main">
               <a:ext uri="{FF2B5EF4-FFF2-40B4-BE49-F238E27FC236}">
-                <a16:creationId xmlns:a16="http://schemas.microsoft.com/office/drawing/2014/main" id="{C37BA7CB-4651-4CA4-90FD-C344469AE2D5}"/>
+                <a16:creationId xmlns:a16="http://schemas.microsoft.com/office/drawing/2014/main" id="{7D5E3CF5-CBEC-46A2-A13D-6F70DB2CAF97}"/>
               </a:ext>
             </a:extLst>
           </p:cNvPr>
@@ -7324,7 +7324,7 @@
                   <a:srgbClr val="262626"/>
                 </a:solidFill>
               </a:rPr>
-              <a:t>• Практическое преимущество не подтверждено</a:t>
+              <a:t>• Значимое и устойчивое преимущество не установлено</a:t>
             </a:r>
           </a:p>
         </p:txBody>
@@ -7338,7 +7338,7 @@
           <p:nvPr/>
         </p:nvPicPr>
         <p:blipFill>
-          <a:blip xmlns:r="http://schemas.openxmlformats.org/officeDocument/2006/relationships" xmlns:a="http://schemas.openxmlformats.org/drawingml/2006/main" r:embed="R3b37c88684d94df6"/>
+          <a:blip xmlns:r="http://schemas.openxmlformats.org/officeDocument/2006/relationships" xmlns:a="http://schemas.openxmlformats.org/drawingml/2006/main" r:embed="R657cec2be4944453"/>
           <a:stretch xmlns:a="http://schemas.openxmlformats.org/drawingml/2006/main"/>
         </p:blipFill>
         <p:spPr>
@@ -7356,7 +7356,7 @@
           <p:cNvPr id="5" name="">
             <a:extLst xmlns:a="http://schemas.openxmlformats.org/drawingml/2006/main">
               <a:ext uri="{FF2B5EF4-FFF2-40B4-BE49-F238E27FC236}">
-                <a16:creationId xmlns:a16="http://schemas.microsoft.com/office/drawing/2014/main" id="{027EEFE5-B93D-4FBB-B8FE-DDBCB51EEE5B}"/>
+                <a16:creationId xmlns:a16="http://schemas.microsoft.com/office/drawing/2014/main" id="{383A87B4-1BAB-4116-9ED3-13CB483B7791}"/>
               </a:ext>
             </a:extLst>
           </p:cNvPr>
@@ -7404,7 +7404,7 @@
     </p:spTree>
     <p:extLst>
       <p:ext uri="{BB962C8B-B14F-4D97-AF65-F5344CB8AC3E}">
-        <p14:creationId xmlns:p14="http://schemas.microsoft.com/office/powerpoint/2010/main" val="217634554"/>
+        <p14:creationId xmlns:p14="http://schemas.microsoft.com/office/powerpoint/2010/main" val="1703507043"/>
       </p:ext>
     </p:extLst>
   </p:cSld>
@@ -7412,7 +7412,7 @@
 </file>
 
 <file path=ppt/slides/slide11.xml><?xml version="1.0" encoding="utf-8"?>
-<p:sld xmlns:p="http://schemas.openxmlformats.org/presentationml/2006/main" showMasterSp="0">
+<p:sld xmlns:p="http://schemas.openxmlformats.org/presentationml/2006/main">
   <p:cSld>
     <p:spTree>
       <p:nvGrpSpPr>
@@ -7428,7 +7428,7 @@
           <p:cNvPr id="6" name="">
             <a:extLst xmlns:a="http://schemas.openxmlformats.org/drawingml/2006/main">
               <a:ext uri="{FF2B5EF4-FFF2-40B4-BE49-F238E27FC236}">
-                <a16:creationId xmlns:a16="http://schemas.microsoft.com/office/drawing/2014/main" id="{077802F8-16B1-4828-ADD4-16547A70A8E4}"/>
+                <a16:creationId xmlns:a16="http://schemas.microsoft.com/office/drawing/2014/main" id="{10DC3EA1-ED48-4B70-BC43-E82077427251}"/>
               </a:ext>
             </a:extLst>
           </p:cNvPr>
@@ -7461,7 +7461,7 @@
           <p:cNvPr id="2" name="">
             <a:extLst xmlns:a="http://schemas.openxmlformats.org/drawingml/2006/main">
               <a:ext uri="{FF2B5EF4-FFF2-40B4-BE49-F238E27FC236}">
-                <a16:creationId xmlns:a16="http://schemas.microsoft.com/office/drawing/2014/main" id="{7851787B-07AA-4470-982D-85EF0A2CF8D0}"/>
+                <a16:creationId xmlns:a16="http://schemas.microsoft.com/office/drawing/2014/main" id="{BD901D91-4FE3-415C-96D1-4D80C867AAA0}"/>
               </a:ext>
             </a:extLst>
           </p:cNvPr>
@@ -7511,7 +7511,7 @@
           <p:cNvPr id="3" name="">
             <a:extLst xmlns:a="http://schemas.openxmlformats.org/drawingml/2006/main">
               <a:ext uri="{FF2B5EF4-FFF2-40B4-BE49-F238E27FC236}">
-                <a16:creationId xmlns:a16="http://schemas.microsoft.com/office/drawing/2014/main" id="{0A221725-A743-4295-B094-7A6EC4D39BCA}"/>
+                <a16:creationId xmlns:a16="http://schemas.microsoft.com/office/drawing/2014/main" id="{05D3BC2B-3221-4DB3-99E5-0040975B7F01}"/>
               </a:ext>
             </a:extLst>
           </p:cNvPr>
@@ -7551,7 +7551,7 @@
                   <a:srgbClr val="262626"/>
                 </a:solidFill>
               </a:rPr>
-              <a:t>• MLP (32,16), early stopping: 76 итераций</a:t>
+              <a:t>• MLP 12–32–16–1; 76 эпох</a:t>
             </a:r>
           </a:p>
           <a:p xmlns:a="http://schemas.openxmlformats.org/drawingml/2006/main">
@@ -7568,7 +7568,7 @@
                   <a:srgbClr val="262626"/>
                 </a:solidFill>
               </a:rPr>
-              <a:t>• Test RMSE 0,944; MAE 0,777</a:t>
+              <a:t>• Восстановлены веса эпохи 35</a:t>
             </a:r>
           </a:p>
           <a:p xmlns:a="http://schemas.openxmlformats.org/drawingml/2006/main">
@@ -7585,7 +7585,7 @@
                   <a:srgbClr val="262626"/>
                 </a:solidFill>
               </a:rPr>
-              <a:t>• Test R² −0,040</a:t>
+              <a:t>• RMSE 0,944; MAE 0,777; R² −0,040</a:t>
             </a:r>
           </a:p>
           <a:p xmlns:a="http://schemas.openxmlformats.org/drawingml/2006/main">
@@ -7602,7 +7602,7 @@
                   <a:srgbClr val="262626"/>
                 </a:solidFill>
               </a:rPr>
-              <a:t>• Хуже baseline; не оптимизация состава</a:t>
+              <a:t>• Хуже константной модели 0,926</a:t>
             </a:r>
           </a:p>
           <a:p xmlns:a="http://schemas.openxmlformats.org/drawingml/2006/main">
@@ -7619,7 +7619,7 @@
                   <a:srgbClr val="262626"/>
                 </a:solidFill>
               </a:rPr>
-              <a:t>• Потери: ½MSE + L2, стандартизованная цель</a:t>
+              <a:t>• L2-штраф применяется к весам</a:t>
             </a:r>
           </a:p>
         </p:txBody>
@@ -7633,13 +7633,13 @@
           <p:nvPr/>
         </p:nvPicPr>
         <p:blipFill>
-          <a:blip xmlns:r="http://schemas.openxmlformats.org/officeDocument/2006/relationships" xmlns:a="http://schemas.openxmlformats.org/drawingml/2006/main" r:embed="R7cb2959184a24a0c"/>
+          <a:blip xmlns:r="http://schemas.openxmlformats.org/officeDocument/2006/relationships" xmlns:a="http://schemas.openxmlformats.org/drawingml/2006/main" r:embed="R44856e8e88104bb5"/>
           <a:stretch xmlns:a="http://schemas.openxmlformats.org/drawingml/2006/main"/>
         </p:blipFill>
         <p:spPr>
           <a:xfrm xmlns:a="http://schemas.openxmlformats.org/drawingml/2006/main">
-            <a:off x="4000500" y="2132671"/>
-            <a:ext cx="7620000" cy="2973659"/>
+            <a:off x="4000500" y="2131147"/>
+            <a:ext cx="7620000" cy="2976705"/>
           </a:xfrm>
           <a:prstGeom xmlns:a="http://schemas.openxmlformats.org/drawingml/2006/main" prst="rect">
             <a:avLst/>
@@ -7651,7 +7651,7 @@
           <p:cNvPr id="5" name="">
             <a:extLst xmlns:a="http://schemas.openxmlformats.org/drawingml/2006/main">
               <a:ext uri="{FF2B5EF4-FFF2-40B4-BE49-F238E27FC236}">
-                <a16:creationId xmlns:a16="http://schemas.microsoft.com/office/drawing/2014/main" id="{A4694C6D-49B8-4727-99E4-D5729143CE58}"/>
+                <a16:creationId xmlns:a16="http://schemas.microsoft.com/office/drawing/2014/main" id="{4254CB21-4B2F-4DD4-9585-60254173C8D9}"/>
               </a:ext>
             </a:extLst>
           </p:cNvPr>
@@ -7699,7 +7699,7 @@
     </p:spTree>
     <p:extLst>
       <p:ext uri="{BB962C8B-B14F-4D97-AF65-F5344CB8AC3E}">
-        <p14:creationId xmlns:p14="http://schemas.microsoft.com/office/powerpoint/2010/main" val="217634554"/>
+        <p14:creationId xmlns:p14="http://schemas.microsoft.com/office/powerpoint/2010/main" val="1703507043"/>
       </p:ext>
     </p:extLst>
   </p:cSld>
@@ -7707,7 +7707,7 @@
 </file>
 
 <file path=ppt/slides/slide12.xml><?xml version="1.0" encoding="utf-8"?>
-<p:sld xmlns:p="http://schemas.openxmlformats.org/presentationml/2006/main" showMasterSp="0">
+<p:sld xmlns:p="http://schemas.openxmlformats.org/presentationml/2006/main">
   <p:cSld>
     <p:spTree>
       <p:nvGrpSpPr>
@@ -7723,7 +7723,7 @@
           <p:cNvPr id="6" name="">
             <a:extLst xmlns:a="http://schemas.openxmlformats.org/drawingml/2006/main">
               <a:ext uri="{FF2B5EF4-FFF2-40B4-BE49-F238E27FC236}">
-                <a16:creationId xmlns:a16="http://schemas.microsoft.com/office/drawing/2014/main" id="{DB624D8B-27F2-41A7-956E-D1C8E068216E}"/>
+                <a16:creationId xmlns:a16="http://schemas.microsoft.com/office/drawing/2014/main" id="{93ED9617-5297-4165-9752-52BE97473F39}"/>
               </a:ext>
             </a:extLst>
           </p:cNvPr>
@@ -7756,7 +7756,7 @@
           <p:cNvPr id="2" name="">
             <a:extLst xmlns:a="http://schemas.openxmlformats.org/drawingml/2006/main">
               <a:ext uri="{FF2B5EF4-FFF2-40B4-BE49-F238E27FC236}">
-                <a16:creationId xmlns:a16="http://schemas.microsoft.com/office/drawing/2014/main" id="{042D7766-7590-468D-959D-708739C941DF}"/>
+                <a16:creationId xmlns:a16="http://schemas.microsoft.com/office/drawing/2014/main" id="{1C30C6E5-22C0-48B2-8401-A3722C3DA04B}"/>
               </a:ext>
             </a:extLst>
           </p:cNvPr>
@@ -7806,7 +7806,7 @@
           <p:cNvPr id="3" name="">
             <a:extLst xmlns:a="http://schemas.openxmlformats.org/drawingml/2006/main">
               <a:ext uri="{FF2B5EF4-FFF2-40B4-BE49-F238E27FC236}">
-                <a16:creationId xmlns:a16="http://schemas.microsoft.com/office/drawing/2014/main" id="{7450113F-56E7-4338-B3FC-786D9AA1D19F}"/>
+                <a16:creationId xmlns:a16="http://schemas.microsoft.com/office/drawing/2014/main" id="{CA3946C1-E643-4E9C-B4A0-C901D51C111D}"/>
               </a:ext>
             </a:extLst>
           </p:cNvPr>
@@ -7846,7 +7846,7 @@
                   <a:srgbClr val="262626"/>
                 </a:solidFill>
               </a:rPr>
-              <a:t>• Permutation importance: test, 10 повторов</a:t>
+              <a:t>• Пермутационная важность: 10 повторов</a:t>
             </a:r>
           </a:p>
           <a:p xmlns:a="http://schemas.openxmlformats.org/drawingml/2006/main">
@@ -7863,7 +7863,7 @@
                   <a:srgbClr val="262626"/>
                 </a:solidFill>
               </a:rPr>
-              <a:t>• Ноль baseline не означает физическую незначимость</a:t>
+              <a:t>• Ноль константной модели не означает физическую незначимость</a:t>
             </a:r>
           </a:p>
           <a:p xmlns:a="http://schemas.openxmlformats.org/drawingml/2006/main">
@@ -7897,7 +7897,7 @@
                   <a:srgbClr val="262626"/>
                 </a:solidFill>
               </a:rPr>
-              <a:t>• Неизвестны группы опытов и происхождение наблюдений</a:t>
+              <a:t>• Перенос на новые материалы не проверен</a:t>
             </a:r>
           </a:p>
         </p:txBody>
@@ -7911,7 +7911,7 @@
           <p:nvPr/>
         </p:nvPicPr>
         <p:blipFill>
-          <a:blip xmlns:r="http://schemas.openxmlformats.org/officeDocument/2006/relationships" xmlns:a="http://schemas.openxmlformats.org/drawingml/2006/main" r:embed="Re90489457748442c"/>
+          <a:blip xmlns:r="http://schemas.openxmlformats.org/officeDocument/2006/relationships" xmlns:a="http://schemas.openxmlformats.org/drawingml/2006/main" r:embed="Rbedd264b4c9e4b0e"/>
           <a:stretch xmlns:a="http://schemas.openxmlformats.org/drawingml/2006/main"/>
         </p:blipFill>
         <p:spPr>
@@ -7929,7 +7929,7 @@
           <p:cNvPr id="5" name="">
             <a:extLst xmlns:a="http://schemas.openxmlformats.org/drawingml/2006/main">
               <a:ext uri="{FF2B5EF4-FFF2-40B4-BE49-F238E27FC236}">
-                <a16:creationId xmlns:a16="http://schemas.microsoft.com/office/drawing/2014/main" id="{2A76D8E1-E378-4764-8DDA-CDC663FE2D8F}"/>
+                <a16:creationId xmlns:a16="http://schemas.microsoft.com/office/drawing/2014/main" id="{EB034728-CA4C-4ED9-BF2D-BC2D944C44C2}"/>
               </a:ext>
             </a:extLst>
           </p:cNvPr>
@@ -7977,7 +7977,7 @@
     </p:spTree>
     <p:extLst>
       <p:ext uri="{BB962C8B-B14F-4D97-AF65-F5344CB8AC3E}">
-        <p14:creationId xmlns:p14="http://schemas.microsoft.com/office/powerpoint/2010/main" val="217634554"/>
+        <p14:creationId xmlns:p14="http://schemas.microsoft.com/office/powerpoint/2010/main" val="1703507043"/>
       </p:ext>
     </p:extLst>
   </p:cSld>
@@ -7985,7 +7985,7 @@
 </file>
 
 <file path=ppt/slides/slide13.xml><?xml version="1.0" encoding="utf-8"?>
-<p:sld xmlns:p="http://schemas.openxmlformats.org/presentationml/2006/main" showMasterSp="0">
+<p:sld xmlns:p="http://schemas.openxmlformats.org/presentationml/2006/main">
   <p:cSld>
     <p:spTree>
       <p:nvGrpSpPr>
@@ -8001,7 +8001,7 @@
           <p:cNvPr id="5" name="">
             <a:extLst xmlns:a="http://schemas.openxmlformats.org/drawingml/2006/main">
               <a:ext uri="{FF2B5EF4-FFF2-40B4-BE49-F238E27FC236}">
-                <a16:creationId xmlns:a16="http://schemas.microsoft.com/office/drawing/2014/main" id="{4A39F52E-3DBE-4132-9D60-0207EF0FFD81}"/>
+                <a16:creationId xmlns:a16="http://schemas.microsoft.com/office/drawing/2014/main" id="{015070E0-09A7-4B8E-BF41-53E0C4B8D866}"/>
               </a:ext>
             </a:extLst>
           </p:cNvPr>
@@ -8034,7 +8034,7 @@
           <p:cNvPr id="2" name="">
             <a:extLst xmlns:a="http://schemas.openxmlformats.org/drawingml/2006/main">
               <a:ext uri="{FF2B5EF4-FFF2-40B4-BE49-F238E27FC236}">
-                <a16:creationId xmlns:a16="http://schemas.microsoft.com/office/drawing/2014/main" id="{04458FFE-DCF4-416D-9359-D3A72ADEAEDC}"/>
+                <a16:creationId xmlns:a16="http://schemas.microsoft.com/office/drawing/2014/main" id="{384870F5-A4A7-4295-A7D5-30082CC38A0B}"/>
               </a:ext>
             </a:extLst>
           </p:cNvPr>
@@ -8084,7 +8084,7 @@
           <p:cNvPr id="3" name="">
             <a:extLst xmlns:a="http://schemas.openxmlformats.org/drawingml/2006/main">
               <a:ext uri="{FF2B5EF4-FFF2-40B4-BE49-F238E27FC236}">
-                <a16:creationId xmlns:a16="http://schemas.microsoft.com/office/drawing/2014/main" id="{2CD4A114-5D48-4EB4-8D35-E99EB6C0F9E0}"/>
+                <a16:creationId xmlns:a16="http://schemas.microsoft.com/office/drawing/2014/main" id="{DB9BB730-94F3-491C-84C6-153625E7207A}"/>
               </a:ext>
             </a:extLst>
           </p:cNvPr>
@@ -8146,24 +8146,7 @@
                   <a:srgbClr val="262626"/>
                 </a:solidFill>
               </a:rPr>
-              <a:t>Демо: 73,2073 ГПа; 2502,06 МПа</a:t>
-            </a:r>
-          </a:p>
-          <a:p xmlns:a="http://schemas.openxmlformats.org/drawingml/2006/main">
-            <a:pPr>
-              <a:defRPr sz="2100">
-                <a:solidFill>
-                  <a:srgbClr val="262626"/>
-                </a:solidFill>
-              </a:defRPr>
-            </a:pPr>
-            <a:r>
-              <a:rPr sz="2100">
-                <a:solidFill>
-                  <a:srgbClr val="262626"/>
-                </a:solidFill>
-              </a:rPr>
-              <a:t>Не измеренный образец.</a:t>
+              <a:t>Медианы в форме — демонстрационный профиль, а не измеренный образец.</a:t>
             </a:r>
           </a:p>
           <a:p xmlns:a="http://schemas.openxmlformats.org/drawingml/2006/main">
@@ -8185,7 +8168,7 @@
                   <a:srgbClr val="262626"/>
                 </a:solidFill>
               </a:rPr>
-              <a:t>Чистый прогон: 35 tests; 24 метрики и 12 276 прогнозов, max Δ=0</a:t>
+              <a:t>Фиксированы данные, разбиение, зависимости, команды, модели и отчёты.</a:t>
             </a:r>
           </a:p>
           <a:p xmlns:a="http://schemas.openxmlformats.org/drawingml/2006/main">
@@ -8202,7 +8185,24 @@
                   <a:srgbClr val="262626"/>
                 </a:solidFill>
               </a:rPr>
-              <a:t>github.com/fpvcstep/composites-property-prediction</a:t>
+              <a:t>github.com/fpvcstep</a:t>
+            </a:r>
+          </a:p>
+          <a:p xmlns:a="http://schemas.openxmlformats.org/drawingml/2006/main">
+            <a:pPr>
+              <a:defRPr sz="2100">
+                <a:solidFill>
+                  <a:srgbClr val="262626"/>
+                </a:solidFill>
+              </a:defRPr>
+            </a:pPr>
+            <a:r>
+              <a:rPr sz="2100">
+                <a:solidFill>
+                  <a:srgbClr val="262626"/>
+                </a:solidFill>
+              </a:rPr>
+              <a:t>…/composites-property-prediction</a:t>
             </a:r>
           </a:p>
         </p:txBody>
@@ -8212,7 +8212,7 @@
           <p:cNvPr id="4" name="">
             <a:extLst xmlns:a="http://schemas.openxmlformats.org/drawingml/2006/main">
               <a:ext uri="{FF2B5EF4-FFF2-40B4-BE49-F238E27FC236}">
-                <a16:creationId xmlns:a16="http://schemas.microsoft.com/office/drawing/2014/main" id="{D657E8B3-05EA-4C99-8299-9F20D793DD68}"/>
+                <a16:creationId xmlns:a16="http://schemas.microsoft.com/office/drawing/2014/main" id="{CFC64B0E-1897-4F87-9F78-63B253C26839}"/>
               </a:ext>
             </a:extLst>
           </p:cNvPr>
@@ -8260,7 +8260,7 @@
     </p:spTree>
     <p:extLst>
       <p:ext uri="{BB962C8B-B14F-4D97-AF65-F5344CB8AC3E}">
-        <p14:creationId xmlns:p14="http://schemas.microsoft.com/office/powerpoint/2010/main" val="217634554"/>
+        <p14:creationId xmlns:p14="http://schemas.microsoft.com/office/powerpoint/2010/main" val="1703507043"/>
       </p:ext>
     </p:extLst>
   </p:cSld>
@@ -8268,7 +8268,7 @@
 </file>
 
 <file path=ppt/slides/slide14.xml><?xml version="1.0" encoding="utf-8"?>
-<p:sld xmlns:p="http://schemas.openxmlformats.org/presentationml/2006/main" showMasterSp="0">
+<p:sld xmlns:p="http://schemas.openxmlformats.org/presentationml/2006/main">
   <p:cSld>
     <p:spTree>
       <p:nvGrpSpPr>
@@ -8284,7 +8284,7 @@
           <p:cNvPr id="5" name="">
             <a:extLst xmlns:a="http://schemas.openxmlformats.org/drawingml/2006/main">
               <a:ext uri="{FF2B5EF4-FFF2-40B4-BE49-F238E27FC236}">
-                <a16:creationId xmlns:a16="http://schemas.microsoft.com/office/drawing/2014/main" id="{A2103DAB-9DC6-4F6D-896D-43D1838D30C4}"/>
+                <a16:creationId xmlns:a16="http://schemas.microsoft.com/office/drawing/2014/main" id="{8A18F925-B586-46FF-B517-2D06688A5011}"/>
               </a:ext>
             </a:extLst>
           </p:cNvPr>
@@ -8317,7 +8317,7 @@
           <p:cNvPr id="2" name="">
             <a:extLst xmlns:a="http://schemas.openxmlformats.org/drawingml/2006/main">
               <a:ext uri="{FF2B5EF4-FFF2-40B4-BE49-F238E27FC236}">
-                <a16:creationId xmlns:a16="http://schemas.microsoft.com/office/drawing/2014/main" id="{3A3EE52E-CF78-46FF-B80C-AC2EDF0022F3}"/>
+                <a16:creationId xmlns:a16="http://schemas.microsoft.com/office/drawing/2014/main" id="{C6B1F57D-D5FB-4055-9101-84917F3BDFF2}"/>
               </a:ext>
             </a:extLst>
           </p:cNvPr>
@@ -8367,7 +8367,7 @@
           <p:cNvPr id="3" name="">
             <a:extLst xmlns:a="http://schemas.openxmlformats.org/drawingml/2006/main">
               <a:ext uri="{FF2B5EF4-FFF2-40B4-BE49-F238E27FC236}">
-                <a16:creationId xmlns:a16="http://schemas.microsoft.com/office/drawing/2014/main" id="{98E5D530-2861-4BE3-8F51-316A515C5E01}"/>
+                <a16:creationId xmlns:a16="http://schemas.microsoft.com/office/drawing/2014/main" id="{B2FBEC37-106D-4D14-AD46-9697EA1D0D83}"/>
               </a:ext>
             </a:extLst>
           </p:cNvPr>
@@ -8378,8 +8378,8 @@
         </p:nvSpPr>
         <p:spPr>
           <a:xfrm xmlns:a="http://schemas.openxmlformats.org/drawingml/2006/main">
-            <a:off x="1000125" y="1524000"/>
-            <a:ext cx="10001250" cy="3810000"/>
+            <a:off x="1000125" y="1381125"/>
+            <a:ext cx="10001250" cy="4191000"/>
           </a:xfrm>
           <a:prstGeom xmlns:a="http://schemas.openxmlformats.org/drawingml/2006/main" prst="rect">
             <a:avLst/>
@@ -8395,70 +8395,87 @@
           <a:lstStyle xmlns:a="http://schemas.openxmlformats.org/drawingml/2006/main"/>
           <a:p xmlns:a="http://schemas.openxmlformats.org/drawingml/2006/main">
             <a:pPr>
-              <a:defRPr sz="2175">
+              <a:defRPr sz="2025">
                 <a:solidFill>
                   <a:srgbClr val="262626"/>
                 </a:solidFill>
               </a:defRPr>
             </a:pPr>
             <a:r>
-              <a:rPr sz="2175">
+              <a:rPr sz="2025">
                 <a:solidFill>
                   <a:srgbClr val="262626"/>
                 </a:solidFill>
               </a:rPr>
-              <a:t>• Сложные модели не дали устойчивого выигрыша</a:t>
+              <a:t>• Модуль: константная модель, R² −0,016</a:t>
             </a:r>
           </a:p>
           <a:p xmlns:a="http://schemas.openxmlformats.org/drawingml/2006/main">
             <a:pPr>
-              <a:defRPr sz="2175">
+              <a:defRPr sz="2025">
                 <a:solidFill>
                   <a:srgbClr val="262626"/>
                 </a:solidFill>
               </a:defRPr>
             </a:pPr>
             <a:r>
-              <a:rPr sz="2175">
+              <a:rPr sz="2025">
                 <a:solidFill>
                   <a:srgbClr val="262626"/>
                 </a:solidFill>
               </a:rPr>
-              <a:t>• Test R²: −0,016; 0,008; −0,040</a:t>
+              <a:t>• Прочность: Gradient Boosting, R² 0,008</a:t>
             </a:r>
           </a:p>
           <a:p xmlns:a="http://schemas.openxmlformats.org/drawingml/2006/main">
             <a:pPr>
-              <a:defRPr sz="2175">
+              <a:defRPr sz="2025">
                 <a:solidFill>
                   <a:srgbClr val="262626"/>
                 </a:solidFill>
               </a:defRPr>
             </a:pPr>
             <a:r>
-              <a:rPr sz="2175">
+              <a:rPr sz="2025">
                 <a:solidFill>
                   <a:srgbClr val="262626"/>
                 </a:solidFill>
               </a:rPr>
-              <a:t>• Результаты ограничены учебным набором</a:t>
+              <a:t>• Обратная регрессия отношения ненадёжна: R² −0,040</a:t>
             </a:r>
           </a:p>
           <a:p xmlns:a="http://schemas.openxmlformats.org/drawingml/2006/main">
             <a:pPr>
-              <a:defRPr sz="2175">
+              <a:defRPr sz="2025">
                 <a:solidFill>
                   <a:srgbClr val="262626"/>
                 </a:solidFill>
               </a:defRPr>
             </a:pPr>
             <a:r>
-              <a:rPr sz="2175">
+              <a:rPr sz="2025">
                 <a:solidFill>
                   <a:srgbClr val="262626"/>
                 </a:solidFill>
               </a:rPr>
-              <a:t>• Прогнозы не заменяют испытания и не определяют оптимальный состав</a:t>
+              <a:t>• Перенос на новые материалы не проверен</a:t>
+            </a:r>
+          </a:p>
+          <a:p xmlns:a="http://schemas.openxmlformats.org/drawingml/2006/main">
+            <a:pPr>
+              <a:defRPr sz="2025">
+                <a:solidFill>
+                  <a:srgbClr val="262626"/>
+                </a:solidFill>
+              </a:defRPr>
+            </a:pPr>
+            <a:r>
+              <a:rPr sz="2025">
+                <a:solidFill>
+                  <a:srgbClr val="262626"/>
+                </a:solidFill>
+              </a:rPr>
+              <a:t>• Требуются паспорт данных и внешние испытания</a:t>
             </a:r>
           </a:p>
           <a:p xmlns:a="http://schemas.openxmlformats.org/drawingml/2006/main">
@@ -8468,14 +8485,14 @@
           </a:p>
           <a:p xmlns:a="http://schemas.openxmlformats.org/drawingml/2006/main">
             <a:pPr>
-              <a:defRPr sz="2175">
+              <a:defRPr sz="2025">
                 <a:solidFill>
                   <a:srgbClr val="262626"/>
                 </a:solidFill>
               </a:defRPr>
             </a:pPr>
             <a:r>
-              <a:rPr sz="2175">
+              <a:rPr sz="2025">
                 <a:solidFill>
                   <a:srgbClr val="262626"/>
                 </a:solidFill>
@@ -8490,7 +8507,7 @@
           <p:cNvPr id="4" name="">
             <a:extLst xmlns:a="http://schemas.openxmlformats.org/drawingml/2006/main">
               <a:ext uri="{FF2B5EF4-FFF2-40B4-BE49-F238E27FC236}">
-                <a16:creationId xmlns:a16="http://schemas.microsoft.com/office/drawing/2014/main" id="{EC3492B0-2A0B-4A56-9C89-6AF3868B3464}"/>
+                <a16:creationId xmlns:a16="http://schemas.microsoft.com/office/drawing/2014/main" id="{D774CCC4-6FD1-4586-9BF9-5FDCF516D615}"/>
               </a:ext>
             </a:extLst>
           </p:cNvPr>
@@ -8538,7 +8555,7 @@
     </p:spTree>
     <p:extLst>
       <p:ext uri="{BB962C8B-B14F-4D97-AF65-F5344CB8AC3E}">
-        <p14:creationId xmlns:p14="http://schemas.microsoft.com/office/powerpoint/2010/main" val="217634554"/>
+        <p14:creationId xmlns:p14="http://schemas.microsoft.com/office/powerpoint/2010/main" val="1703507043"/>
       </p:ext>
     </p:extLst>
   </p:cSld>
@@ -8546,7 +8563,7 @@
 </file>
 
 <file path=ppt/slides/slide2.xml><?xml version="1.0" encoding="utf-8"?>
-<p:sld xmlns:p="http://schemas.openxmlformats.org/presentationml/2006/main" showMasterSp="0">
+<p:sld xmlns:p="http://schemas.openxmlformats.org/presentationml/2006/main">
   <p:cSld>
     <p:spTree>
       <p:nvGrpSpPr>
@@ -8562,7 +8579,7 @@
           <p:cNvPr id="5" name="">
             <a:extLst xmlns:a="http://schemas.openxmlformats.org/drawingml/2006/main">
               <a:ext uri="{FF2B5EF4-FFF2-40B4-BE49-F238E27FC236}">
-                <a16:creationId xmlns:a16="http://schemas.microsoft.com/office/drawing/2014/main" id="{67B61526-E7D5-41CB-8966-400E297629EF}"/>
+                <a16:creationId xmlns:a16="http://schemas.microsoft.com/office/drawing/2014/main" id="{298058B2-7348-4729-8AA3-D6B476E51AEC}"/>
               </a:ext>
             </a:extLst>
           </p:cNvPr>
@@ -8595,7 +8612,7 @@
           <p:cNvPr id="2" name="">
             <a:extLst xmlns:a="http://schemas.openxmlformats.org/drawingml/2006/main">
               <a:ext uri="{FF2B5EF4-FFF2-40B4-BE49-F238E27FC236}">
-                <a16:creationId xmlns:a16="http://schemas.microsoft.com/office/drawing/2014/main" id="{DD982DE6-77CB-4A0B-8D17-3CF40571500B}"/>
+                <a16:creationId xmlns:a16="http://schemas.microsoft.com/office/drawing/2014/main" id="{4C4215C3-8FFD-4A85-96AB-E83469603C86}"/>
               </a:ext>
             </a:extLst>
           </p:cNvPr>
@@ -8645,7 +8662,7 @@
           <p:cNvPr id="3" name="">
             <a:extLst xmlns:a="http://schemas.openxmlformats.org/drawingml/2006/main">
               <a:ext uri="{FF2B5EF4-FFF2-40B4-BE49-F238E27FC236}">
-                <a16:creationId xmlns:a16="http://schemas.microsoft.com/office/drawing/2014/main" id="{9E702D63-D867-4D0B-BA4D-12BC1380266E}"/>
+                <a16:creationId xmlns:a16="http://schemas.microsoft.com/office/drawing/2014/main" id="{D07D9648-0F64-43B8-B15C-883117A07F87}"/>
               </a:ext>
             </a:extLst>
           </p:cNvPr>
@@ -8702,7 +8719,7 @@
                   <a:srgbClr val="262626"/>
                 </a:solidFill>
               </a:rPr>
-              <a:t>• Учебная оценка отношения матрица–наполнитель</a:t>
+              <a:t>• Обратная регрессия отношения матрица–наполнитель</a:t>
             </a:r>
           </a:p>
           <a:p xmlns:a="http://schemas.openxmlformats.org/drawingml/2006/main">
@@ -8719,7 +8736,7 @@
                   <a:srgbClr val="262626"/>
                 </a:solidFill>
               </a:rPr>
-              <a:t>• Честная валидация без утечки</a:t>
+              <a:t>• Оценка без утечки информации</a:t>
             </a:r>
           </a:p>
           <a:p xmlns:a="http://schemas.openxmlformats.org/drawingml/2006/main">
@@ -8746,7 +8763,7 @@
           <p:cNvPr id="4" name="">
             <a:extLst xmlns:a="http://schemas.openxmlformats.org/drawingml/2006/main">
               <a:ext uri="{FF2B5EF4-FFF2-40B4-BE49-F238E27FC236}">
-                <a16:creationId xmlns:a16="http://schemas.microsoft.com/office/drawing/2014/main" id="{7327CAEC-3489-4B0F-BBDC-438F42DA2E58}"/>
+                <a16:creationId xmlns:a16="http://schemas.microsoft.com/office/drawing/2014/main" id="{37D74786-BC23-4DEB-8E3F-F7A92BD60736}"/>
               </a:ext>
             </a:extLst>
           </p:cNvPr>
@@ -8794,7 +8811,7 @@
     </p:spTree>
     <p:extLst>
       <p:ext uri="{BB962C8B-B14F-4D97-AF65-F5344CB8AC3E}">
-        <p14:creationId xmlns:p14="http://schemas.microsoft.com/office/powerpoint/2010/main" val="217634554"/>
+        <p14:creationId xmlns:p14="http://schemas.microsoft.com/office/powerpoint/2010/main" val="1703507043"/>
       </p:ext>
     </p:extLst>
   </p:cSld>
@@ -8802,7 +8819,7 @@
 </file>
 
 <file path=ppt/slides/slide3.xml><?xml version="1.0" encoding="utf-8"?>
-<p:sld xmlns:p="http://schemas.openxmlformats.org/presentationml/2006/main" showMasterSp="0">
+<p:sld xmlns:p="http://schemas.openxmlformats.org/presentationml/2006/main">
   <p:cSld>
     <p:spTree>
       <p:nvGrpSpPr>
@@ -8818,7 +8835,7 @@
           <p:cNvPr id="5" name="">
             <a:extLst xmlns:a="http://schemas.openxmlformats.org/drawingml/2006/main">
               <a:ext uri="{FF2B5EF4-FFF2-40B4-BE49-F238E27FC236}">
-                <a16:creationId xmlns:a16="http://schemas.microsoft.com/office/drawing/2014/main" id="{B583F922-F296-462A-858E-B56F4898F09D}"/>
+                <a16:creationId xmlns:a16="http://schemas.microsoft.com/office/drawing/2014/main" id="{D8B45AAD-7C6B-4D77-AD35-2CDCCCDB80C3}"/>
               </a:ext>
             </a:extLst>
           </p:cNvPr>
@@ -8851,7 +8868,7 @@
           <p:cNvPr id="2" name="">
             <a:extLst xmlns:a="http://schemas.openxmlformats.org/drawingml/2006/main">
               <a:ext uri="{FF2B5EF4-FFF2-40B4-BE49-F238E27FC236}">
-                <a16:creationId xmlns:a16="http://schemas.microsoft.com/office/drawing/2014/main" id="{1D4D6044-C2EC-4730-AE67-725C8A6BB17E}"/>
+                <a16:creationId xmlns:a16="http://schemas.microsoft.com/office/drawing/2014/main" id="{B6C2C1AC-BE07-434A-9176-B539B65EFDD6}"/>
               </a:ext>
             </a:extLst>
           </p:cNvPr>
@@ -8901,7 +8918,7 @@
           <p:cNvPr id="3" name="">
             <a:extLst xmlns:a="http://schemas.openxmlformats.org/drawingml/2006/main">
               <a:ext uri="{FF2B5EF4-FFF2-40B4-BE49-F238E27FC236}">
-                <a16:creationId xmlns:a16="http://schemas.microsoft.com/office/drawing/2014/main" id="{8B5BEB57-170D-4FD1-881C-92EDEDDA0E12}"/>
+                <a16:creationId xmlns:a16="http://schemas.microsoft.com/office/drawing/2014/main" id="{7B0B64CE-3399-4EA4-9F9D-0E3D8900E1AA}"/>
               </a:ext>
             </a:extLst>
           </p:cNvPr>
@@ -9002,7 +9019,7 @@
           <p:cNvPr id="4" name="">
             <a:extLst xmlns:a="http://schemas.openxmlformats.org/drawingml/2006/main">
               <a:ext uri="{FF2B5EF4-FFF2-40B4-BE49-F238E27FC236}">
-                <a16:creationId xmlns:a16="http://schemas.microsoft.com/office/drawing/2014/main" id="{8BCFE5C2-3A44-4992-90F8-A2FBFE6A7EF4}"/>
+                <a16:creationId xmlns:a16="http://schemas.microsoft.com/office/drawing/2014/main" id="{E49194E3-9155-47EA-B991-60A8CB036C7A}"/>
               </a:ext>
             </a:extLst>
           </p:cNvPr>
@@ -9050,7 +9067,7 @@
     </p:spTree>
     <p:extLst>
       <p:ext uri="{BB962C8B-B14F-4D97-AF65-F5344CB8AC3E}">
-        <p14:creationId xmlns:p14="http://schemas.microsoft.com/office/powerpoint/2010/main" val="217634554"/>
+        <p14:creationId xmlns:p14="http://schemas.microsoft.com/office/powerpoint/2010/main" val="1703507043"/>
       </p:ext>
     </p:extLst>
   </p:cSld>
@@ -9058,7 +9075,7 @@
 </file>
 
 <file path=ppt/slides/slide4.xml><?xml version="1.0" encoding="utf-8"?>
-<p:sld xmlns:p="http://schemas.openxmlformats.org/presentationml/2006/main" showMasterSp="0">
+<p:sld xmlns:p="http://schemas.openxmlformats.org/presentationml/2006/main">
   <p:cSld>
     <p:spTree>
       <p:nvGrpSpPr>
@@ -9074,7 +9091,7 @@
           <p:cNvPr id="6" name="">
             <a:extLst xmlns:a="http://schemas.openxmlformats.org/drawingml/2006/main">
               <a:ext uri="{FF2B5EF4-FFF2-40B4-BE49-F238E27FC236}">
-                <a16:creationId xmlns:a16="http://schemas.microsoft.com/office/drawing/2014/main" id="{2EDA159B-C28C-4E84-B0D8-DFE5510F8C80}"/>
+                <a16:creationId xmlns:a16="http://schemas.microsoft.com/office/drawing/2014/main" id="{C0E940E0-8878-4ECC-BEB8-3328B242EE3C}"/>
               </a:ext>
             </a:extLst>
           </p:cNvPr>
@@ -9107,7 +9124,7 @@
           <p:cNvPr id="2" name="">
             <a:extLst xmlns:a="http://schemas.openxmlformats.org/drawingml/2006/main">
               <a:ext uri="{FF2B5EF4-FFF2-40B4-BE49-F238E27FC236}">
-                <a16:creationId xmlns:a16="http://schemas.microsoft.com/office/drawing/2014/main" id="{487449F8-57DE-4C23-9C7D-31E833B33A53}"/>
+                <a16:creationId xmlns:a16="http://schemas.microsoft.com/office/drawing/2014/main" id="{07F42D9C-1789-4463-9297-12EDFF5077DA}"/>
               </a:ext>
             </a:extLst>
           </p:cNvPr>
@@ -9157,7 +9174,7 @@
           <p:cNvPr id="3" name="">
             <a:extLst xmlns:a="http://schemas.openxmlformats.org/drawingml/2006/main">
               <a:ext uri="{FF2B5EF4-FFF2-40B4-BE49-F238E27FC236}">
-                <a16:creationId xmlns:a16="http://schemas.microsoft.com/office/drawing/2014/main" id="{55CEDFE2-58B8-4C6F-B47B-0E03E5731868}"/>
+                <a16:creationId xmlns:a16="http://schemas.microsoft.com/office/drawing/2014/main" id="{8A479F45-E6CC-4F86-A8AC-A7C8FB41A886}"/>
               </a:ext>
             </a:extLst>
           </p:cNvPr>
@@ -9197,7 +9214,7 @@
                   <a:srgbClr val="262626"/>
                 </a:solidFill>
               </a:rPr>
-              <a:t>• Train 716; test 307; random_state=42</a:t>
+              <a:t>• Обучение: 716; отложенная оценка: 307</a:t>
             </a:r>
           </a:p>
           <a:p xmlns:a="http://schemas.openxmlformats.org/drawingml/2006/main">
@@ -9214,7 +9231,7 @@
                   <a:srgbClr val="262626"/>
                 </a:solidFill>
               </a:rPr>
-              <a:t>• GridSearchCV, 10 фолдов, только train</a:t>
+              <a:t>• GridSearchCV: 10 фолдов обучающей части</a:t>
             </a:r>
           </a:p>
           <a:p xmlns:a="http://schemas.openxmlformats.org/drawingml/2006/main">
@@ -9231,7 +9248,7 @@
                   <a:srgbClr val="262626"/>
                 </a:solidFill>
               </a:rPr>
-              <a:t>• Fit StandardScaler внутри CV для Ridge, SVR, MLP</a:t>
+              <a:t>• StandardScaler оценивается внутри каждого фолда</a:t>
             </a:r>
           </a:p>
           <a:p xmlns:a="http://schemas.openxmlformats.org/drawingml/2006/main">
@@ -9248,7 +9265,7 @@
                   <a:srgbClr val="262626"/>
                 </a:solidFill>
               </a:rPr>
-              <a:t>• Test открыт после фиксации моделей</a:t>
+              <a:t>• Итоговая оценка после фиксации моделей</a:t>
             </a:r>
           </a:p>
         </p:txBody>
@@ -9262,7 +9279,7 @@
           <p:nvPr/>
         </p:nvPicPr>
         <p:blipFill>
-          <a:blip xmlns:r="http://schemas.openxmlformats.org/officeDocument/2006/relationships" xmlns:a="http://schemas.openxmlformats.org/drawingml/2006/main" r:embed="R57c5b1695c5c40e4"/>
+          <a:blip xmlns:r="http://schemas.openxmlformats.org/officeDocument/2006/relationships" xmlns:a="http://schemas.openxmlformats.org/drawingml/2006/main" r:embed="Rf847f11d666846fd"/>
           <a:stretch xmlns:a="http://schemas.openxmlformats.org/drawingml/2006/main"/>
         </p:blipFill>
         <p:spPr>
@@ -9280,7 +9297,7 @@
           <p:cNvPr id="5" name="">
             <a:extLst xmlns:a="http://schemas.openxmlformats.org/drawingml/2006/main">
               <a:ext uri="{FF2B5EF4-FFF2-40B4-BE49-F238E27FC236}">
-                <a16:creationId xmlns:a16="http://schemas.microsoft.com/office/drawing/2014/main" id="{C5DE3127-329C-4B7F-813E-1409395F9771}"/>
+                <a16:creationId xmlns:a16="http://schemas.microsoft.com/office/drawing/2014/main" id="{486EEF8F-29D6-4752-88C6-71CC6FFA16A1}"/>
               </a:ext>
             </a:extLst>
           </p:cNvPr>
@@ -9328,7 +9345,7 @@
     </p:spTree>
     <p:extLst>
       <p:ext uri="{BB962C8B-B14F-4D97-AF65-F5344CB8AC3E}">
-        <p14:creationId xmlns:p14="http://schemas.microsoft.com/office/powerpoint/2010/main" val="217634554"/>
+        <p14:creationId xmlns:p14="http://schemas.microsoft.com/office/powerpoint/2010/main" val="1703507043"/>
       </p:ext>
     </p:extLst>
   </p:cSld>
@@ -9336,7 +9353,7 @@
 </file>
 
 <file path=ppt/slides/slide5.xml><?xml version="1.0" encoding="utf-8"?>
-<p:sld xmlns:p="http://schemas.openxmlformats.org/presentationml/2006/main" showMasterSp="0">
+<p:sld xmlns:p="http://schemas.openxmlformats.org/presentationml/2006/main">
   <p:cSld>
     <p:spTree>
       <p:nvGrpSpPr>
@@ -9352,7 +9369,7 @@
           <p:cNvPr id="6" name="">
             <a:extLst xmlns:a="http://schemas.openxmlformats.org/drawingml/2006/main">
               <a:ext uri="{FF2B5EF4-FFF2-40B4-BE49-F238E27FC236}">
-                <a16:creationId xmlns:a16="http://schemas.microsoft.com/office/drawing/2014/main" id="{245681DA-E72B-4778-B2FD-1A1CE0FC17E2}"/>
+                <a16:creationId xmlns:a16="http://schemas.microsoft.com/office/drawing/2014/main" id="{31D73BFB-B6D0-4DA6-B49E-F280B972CE2A}"/>
               </a:ext>
             </a:extLst>
           </p:cNvPr>
@@ -9385,7 +9402,7 @@
           <p:cNvPr id="2" name="">
             <a:extLst xmlns:a="http://schemas.openxmlformats.org/drawingml/2006/main">
               <a:ext uri="{FF2B5EF4-FFF2-40B4-BE49-F238E27FC236}">
-                <a16:creationId xmlns:a16="http://schemas.microsoft.com/office/drawing/2014/main" id="{E5645B3D-8476-4FCD-923E-A9C983098BE0}"/>
+                <a16:creationId xmlns:a16="http://schemas.microsoft.com/office/drawing/2014/main" id="{DFA6A850-F96E-4E22-9712-94439CE08A9B}"/>
               </a:ext>
             </a:extLst>
           </p:cNvPr>
@@ -9435,7 +9452,7 @@
           <p:cNvPr id="3" name="">
             <a:extLst xmlns:a="http://schemas.openxmlformats.org/drawingml/2006/main">
               <a:ext uri="{FF2B5EF4-FFF2-40B4-BE49-F238E27FC236}">
-                <a16:creationId xmlns:a16="http://schemas.microsoft.com/office/drawing/2014/main" id="{E5DC120A-4F51-4FFB-9801-37EDE9F077F1}"/>
+                <a16:creationId xmlns:a16="http://schemas.microsoft.com/office/drawing/2014/main" id="{E23F28D5-A6CC-486F-BCA5-3592600F0B40}"/>
               </a:ext>
             </a:extLst>
           </p:cNvPr>
@@ -9540,7 +9557,7 @@
           <p:nvPr/>
         </p:nvPicPr>
         <p:blipFill>
-          <a:blip xmlns:r="http://schemas.openxmlformats.org/officeDocument/2006/relationships" xmlns:a="http://schemas.openxmlformats.org/drawingml/2006/main" r:embed="R6bd4e0c0b72d4d9c"/>
+          <a:blip xmlns:r="http://schemas.openxmlformats.org/officeDocument/2006/relationships" xmlns:a="http://schemas.openxmlformats.org/drawingml/2006/main" r:embed="R3dc8877e48614bbd"/>
           <a:stretch xmlns:a="http://schemas.openxmlformats.org/drawingml/2006/main"/>
         </p:blipFill>
         <p:spPr>
@@ -9558,7 +9575,7 @@
           <p:cNvPr id="5" name="">
             <a:extLst xmlns:a="http://schemas.openxmlformats.org/drawingml/2006/main">
               <a:ext uri="{FF2B5EF4-FFF2-40B4-BE49-F238E27FC236}">
-                <a16:creationId xmlns:a16="http://schemas.microsoft.com/office/drawing/2014/main" id="{09842674-CCFE-4D67-BA07-D996CD6EEBD9}"/>
+                <a16:creationId xmlns:a16="http://schemas.microsoft.com/office/drawing/2014/main" id="{4C29505D-909D-4A9A-B592-BCDF7390014C}"/>
               </a:ext>
             </a:extLst>
           </p:cNvPr>
@@ -9606,7 +9623,7 @@
     </p:spTree>
     <p:extLst>
       <p:ext uri="{BB962C8B-B14F-4D97-AF65-F5344CB8AC3E}">
-        <p14:creationId xmlns:p14="http://schemas.microsoft.com/office/powerpoint/2010/main" val="217634554"/>
+        <p14:creationId xmlns:p14="http://schemas.microsoft.com/office/powerpoint/2010/main" val="1703507043"/>
       </p:ext>
     </p:extLst>
   </p:cSld>
@@ -9614,7 +9631,7 @@
 </file>
 
 <file path=ppt/slides/slide6.xml><?xml version="1.0" encoding="utf-8"?>
-<p:sld xmlns:p="http://schemas.openxmlformats.org/presentationml/2006/main" showMasterSp="0">
+<p:sld xmlns:p="http://schemas.openxmlformats.org/presentationml/2006/main">
   <p:cSld>
     <p:spTree>
       <p:nvGrpSpPr>
@@ -9630,7 +9647,7 @@
           <p:cNvPr id="5" name="">
             <a:extLst xmlns:a="http://schemas.openxmlformats.org/drawingml/2006/main">
               <a:ext uri="{FF2B5EF4-FFF2-40B4-BE49-F238E27FC236}">
-                <a16:creationId xmlns:a16="http://schemas.microsoft.com/office/drawing/2014/main" id="{39454C28-4906-4E3B-965D-8AF027AA7999}"/>
+                <a16:creationId xmlns:a16="http://schemas.microsoft.com/office/drawing/2014/main" id="{057AD552-C743-431E-AEF5-021713157D60}"/>
               </a:ext>
             </a:extLst>
           </p:cNvPr>
@@ -9663,7 +9680,7 @@
           <p:cNvPr id="2" name="">
             <a:extLst xmlns:a="http://schemas.openxmlformats.org/drawingml/2006/main">
               <a:ext uri="{FF2B5EF4-FFF2-40B4-BE49-F238E27FC236}">
-                <a16:creationId xmlns:a16="http://schemas.microsoft.com/office/drawing/2014/main" id="{C13F10B3-8D42-49CF-B577-B25EA4A7F42C}"/>
+                <a16:creationId xmlns:a16="http://schemas.microsoft.com/office/drawing/2014/main" id="{782B2D18-3CD2-4891-9456-3F271648D332}"/>
               </a:ext>
             </a:extLst>
           </p:cNvPr>
@@ -9713,7 +9730,7 @@
           <p:cNvPr id="3" name="">
             <a:extLst xmlns:a="http://schemas.openxmlformats.org/drawingml/2006/main">
               <a:ext uri="{FF2B5EF4-FFF2-40B4-BE49-F238E27FC236}">
-                <a16:creationId xmlns:a16="http://schemas.microsoft.com/office/drawing/2014/main" id="{1D06A8DA-95A0-4A1C-A51F-DFB1D804E20E}"/>
+                <a16:creationId xmlns:a16="http://schemas.microsoft.com/office/drawing/2014/main" id="{58786501-6FB5-45AE-A677-3BE5DB2E9ACD}"/>
               </a:ext>
             </a:extLst>
           </p:cNvPr>
@@ -9770,7 +9787,7 @@
                   <a:srgbClr val="262626"/>
                 </a:solidFill>
               </a:rPr>
-              <a:t>• MinMax — только иллюстрация 13 распределений</a:t>
+              <a:t>• IQR: прямые задачи 716 → 663</a:t>
             </a:r>
           </a:p>
           <a:p xmlns:a="http://schemas.openxmlformats.org/drawingml/2006/main">
@@ -9787,7 +9804,7 @@
                   <a:srgbClr val="262626"/>
                 </a:solidFill>
               </a:rPr>
-              <a:t>• StandardScaler X/y — внутри CV pipeline</a:t>
+              <a:t>• IQR: отношение 716 → 655</a:t>
             </a:r>
           </a:p>
           <a:p xmlns:a="http://schemas.openxmlformats.org/drawingml/2006/main">
@@ -9804,7 +9821,7 @@
                   <a:srgbClr val="262626"/>
                 </a:solidFill>
               </a:rPr>
-              <a:t>• Деревья работают в исходном масштабе</a:t>
+              <a:t>• Границы оцениваются внутри обучающей части фолда</a:t>
             </a:r>
           </a:p>
           <a:p xmlns:a="http://schemas.openxmlformats.org/drawingml/2006/main">
@@ -9821,7 +9838,7 @@
                   <a:srgbClr val="262626"/>
                 </a:solidFill>
               </a:rPr>
-              <a:t>• Отношение не объявляется массовым или объёмным</a:t>
+              <a:t>• Выбран вариант без удаления</a:t>
             </a:r>
           </a:p>
         </p:txBody>
@@ -9831,7 +9848,7 @@
           <p:cNvPr id="4" name="">
             <a:extLst xmlns:a="http://schemas.openxmlformats.org/drawingml/2006/main">
               <a:ext uri="{FF2B5EF4-FFF2-40B4-BE49-F238E27FC236}">
-                <a16:creationId xmlns:a16="http://schemas.microsoft.com/office/drawing/2014/main" id="{F51A50F4-87A0-4309-A52C-7F057B76AB4D}"/>
+                <a16:creationId xmlns:a16="http://schemas.microsoft.com/office/drawing/2014/main" id="{48368F95-D909-40FE-A584-296B4D02B0F1}"/>
               </a:ext>
             </a:extLst>
           </p:cNvPr>
@@ -9879,7 +9896,7 @@
     </p:spTree>
     <p:extLst>
       <p:ext uri="{BB962C8B-B14F-4D97-AF65-F5344CB8AC3E}">
-        <p14:creationId xmlns:p14="http://schemas.microsoft.com/office/powerpoint/2010/main" val="217634554"/>
+        <p14:creationId xmlns:p14="http://schemas.microsoft.com/office/powerpoint/2010/main" val="1703507043"/>
       </p:ext>
     </p:extLst>
   </p:cSld>
@@ -9887,7 +9904,7 @@
 </file>
 
 <file path=ppt/slides/slide7.xml><?xml version="1.0" encoding="utf-8"?>
-<p:sld xmlns:p="http://schemas.openxmlformats.org/presentationml/2006/main" showMasterSp="0">
+<p:sld xmlns:p="http://schemas.openxmlformats.org/presentationml/2006/main">
   <p:cSld>
     <p:spTree>
       <p:nvGrpSpPr>
@@ -9903,7 +9920,7 @@
           <p:cNvPr id="5" name="">
             <a:extLst xmlns:a="http://schemas.openxmlformats.org/drawingml/2006/main">
               <a:ext uri="{FF2B5EF4-FFF2-40B4-BE49-F238E27FC236}">
-                <a16:creationId xmlns:a16="http://schemas.microsoft.com/office/drawing/2014/main" id="{13AA1FBF-941A-47DC-BD3C-942C664CD65A}"/>
+                <a16:creationId xmlns:a16="http://schemas.microsoft.com/office/drawing/2014/main" id="{CFB84945-B7DF-4D33-B90A-C1A40293B1C7}"/>
               </a:ext>
             </a:extLst>
           </p:cNvPr>
@@ -9936,7 +9953,7 @@
           <p:cNvPr id="2" name="">
             <a:extLst xmlns:a="http://schemas.openxmlformats.org/drawingml/2006/main">
               <a:ext uri="{FF2B5EF4-FFF2-40B4-BE49-F238E27FC236}">
-                <a16:creationId xmlns:a16="http://schemas.microsoft.com/office/drawing/2014/main" id="{915F46DF-04DC-4775-BC5C-BA17AF6B0BED}"/>
+                <a16:creationId xmlns:a16="http://schemas.microsoft.com/office/drawing/2014/main" id="{A45FAEBC-C065-4746-9562-997316E9D305}"/>
               </a:ext>
             </a:extLst>
           </p:cNvPr>
@@ -9986,7 +10003,7 @@
           <p:cNvPr id="3" name="">
             <a:extLst xmlns:a="http://schemas.openxmlformats.org/drawingml/2006/main">
               <a:ext uri="{FF2B5EF4-FFF2-40B4-BE49-F238E27FC236}">
-                <a16:creationId xmlns:a16="http://schemas.microsoft.com/office/drawing/2014/main" id="{B4E8A735-2B52-4267-AE58-F7FABDC1AFA3}"/>
+                <a16:creationId xmlns:a16="http://schemas.microsoft.com/office/drawing/2014/main" id="{B8D334E6-BA53-45A2-B43C-6E85EC34F48A}"/>
               </a:ext>
             </a:extLst>
           </p:cNvPr>
@@ -10026,7 +10043,7 @@
                   <a:srgbClr val="262626"/>
                 </a:solidFill>
               </a:rPr>
-              <a:t>• Baseline и Ridge</a:t>
+              <a:t>• Константная модель и Ridge</a:t>
             </a:r>
           </a:p>
           <a:p xmlns:a="http://schemas.openxmlformats.org/drawingml/2006/main">
@@ -10077,7 +10094,7 @@
                   <a:srgbClr val="262626"/>
                 </a:solidFill>
               </a:rPr>
-              <a:t>• MLPRegressor (32, 16), alpha=0,01</a:t>
+              <a:t>• MLPRegressor 12–32–16–1, alpha=0,01</a:t>
             </a:r>
           </a:p>
           <a:p xmlns:a="http://schemas.openxmlformats.org/drawingml/2006/main">
@@ -10104,7 +10121,7 @@
           <p:cNvPr id="4" name="">
             <a:extLst xmlns:a="http://schemas.openxmlformats.org/drawingml/2006/main">
               <a:ext uri="{FF2B5EF4-FFF2-40B4-BE49-F238E27FC236}">
-                <a16:creationId xmlns:a16="http://schemas.microsoft.com/office/drawing/2014/main" id="{DC683090-9C6E-409D-89D5-0C5CE7E9FC13}"/>
+                <a16:creationId xmlns:a16="http://schemas.microsoft.com/office/drawing/2014/main" id="{01061F16-9743-47C4-9EB5-B67D14B46BE2}"/>
               </a:ext>
             </a:extLst>
           </p:cNvPr>
@@ -10152,7 +10169,7 @@
     </p:spTree>
     <p:extLst>
       <p:ext uri="{BB962C8B-B14F-4D97-AF65-F5344CB8AC3E}">
-        <p14:creationId xmlns:p14="http://schemas.microsoft.com/office/powerpoint/2010/main" val="217634554"/>
+        <p14:creationId xmlns:p14="http://schemas.microsoft.com/office/powerpoint/2010/main" val="1703507043"/>
       </p:ext>
     </p:extLst>
   </p:cSld>
@@ -10160,7 +10177,7 @@
 </file>
 
 <file path=ppt/slides/slide8.xml><?xml version="1.0" encoding="utf-8"?>
-<p:sld xmlns:p="http://schemas.openxmlformats.org/presentationml/2006/main" showMasterSp="0">
+<p:sld xmlns:p="http://schemas.openxmlformats.org/presentationml/2006/main">
   <p:cSld>
     <p:spTree>
       <p:nvGrpSpPr>
@@ -10176,7 +10193,7 @@
           <p:cNvPr id="5" name="">
             <a:extLst xmlns:a="http://schemas.openxmlformats.org/drawingml/2006/main">
               <a:ext uri="{FF2B5EF4-FFF2-40B4-BE49-F238E27FC236}">
-                <a16:creationId xmlns:a16="http://schemas.microsoft.com/office/drawing/2014/main" id="{48A47B00-599E-4948-9A2B-49DF2BC874E2}"/>
+                <a16:creationId xmlns:a16="http://schemas.microsoft.com/office/drawing/2014/main" id="{03398595-E840-4ED0-9ACD-F936D2CD83AA}"/>
               </a:ext>
             </a:extLst>
           </p:cNvPr>
@@ -10209,7 +10226,7 @@
           <p:cNvPr id="2" name="">
             <a:extLst xmlns:a="http://schemas.openxmlformats.org/drawingml/2006/main">
               <a:ext uri="{FF2B5EF4-FFF2-40B4-BE49-F238E27FC236}">
-                <a16:creationId xmlns:a16="http://schemas.microsoft.com/office/drawing/2014/main" id="{F18A6414-E3BE-4125-AB15-FB4B181EA514}"/>
+                <a16:creationId xmlns:a16="http://schemas.microsoft.com/office/drawing/2014/main" id="{39CA4A5F-4761-4D15-8518-73F8E7DA221B}"/>
               </a:ext>
             </a:extLst>
           </p:cNvPr>
@@ -10259,7 +10276,7 @@
           <p:cNvPr id="3" name="">
             <a:extLst xmlns:a="http://schemas.openxmlformats.org/drawingml/2006/main">
               <a:ext uri="{FF2B5EF4-FFF2-40B4-BE49-F238E27FC236}">
-                <a16:creationId xmlns:a16="http://schemas.microsoft.com/office/drawing/2014/main" id="{F5A205D5-7FD9-41E6-AE58-C636A7481F74}"/>
+                <a16:creationId xmlns:a16="http://schemas.microsoft.com/office/drawing/2014/main" id="{D0237991-BB39-453D-9463-2316FBD616BF}"/>
               </a:ext>
             </a:extLst>
           </p:cNvPr>
@@ -10299,7 +10316,7 @@
                   <a:srgbClr val="262626"/>
                 </a:solidFill>
               </a:rPr>
-              <a:t>• Модуль: baseline, RMSE 3,087 ± 0,257 ГПа</a:t>
+              <a:t>• Модуль: константная модель, 3,087 ± 0,257 ГПа</a:t>
             </a:r>
           </a:p>
           <a:p xmlns:a="http://schemas.openxmlformats.org/drawingml/2006/main">
@@ -10316,7 +10333,7 @@
                   <a:srgbClr val="262626"/>
                 </a:solidFill>
               </a:rPr>
-              <a:t>• Прочность: GBR 490,209 ± 23,852 МПа</a:t>
+              <a:t>• Прочность: Gradient Boosting, 490,209 ± 23,852 МПа</a:t>
             </a:r>
           </a:p>
           <a:p xmlns:a="http://schemas.openxmlformats.org/drawingml/2006/main">
@@ -10333,7 +10350,7 @@
                   <a:srgbClr val="262626"/>
                 </a:solidFill>
               </a:rPr>
-              <a:t>• Преимущество GBR над baseline лишь 0,291 МПа</a:t>
+              <a:t>• Gradient Boosting лучше в 4 из 10 фолдов</a:t>
             </a:r>
           </a:p>
           <a:p xmlns:a="http://schemas.openxmlformats.org/drawingml/2006/main">
@@ -10350,7 +10367,24 @@
                   <a:srgbClr val="262626"/>
                 </a:solidFill>
               </a:rPr>
-              <a:t>• MLP 0,935 хуже baseline 0,906</a:t>
+              <a:t>• Парная разность +0,291 ± 8,345 МПа</a:t>
+            </a:r>
+          </a:p>
+          <a:p xmlns:a="http://schemas.openxmlformats.org/drawingml/2006/main">
+            <a:pPr>
+              <a:defRPr sz="2100">
+                <a:solidFill>
+                  <a:srgbClr val="262626"/>
+                </a:solidFill>
+              </a:defRPr>
+            </a:pPr>
+            <a:r>
+              <a:rPr sz="2100">
+                <a:solidFill>
+                  <a:srgbClr val="262626"/>
+                </a:solidFill>
+              </a:rPr>
+              <a:t>• MLP 0,935 хуже константной модели 0,906</a:t>
             </a:r>
           </a:p>
         </p:txBody>
@@ -10360,7 +10394,7 @@
           <p:cNvPr id="4" name="">
             <a:extLst xmlns:a="http://schemas.openxmlformats.org/drawingml/2006/main">
               <a:ext uri="{FF2B5EF4-FFF2-40B4-BE49-F238E27FC236}">
-                <a16:creationId xmlns:a16="http://schemas.microsoft.com/office/drawing/2014/main" id="{D7629CBB-0138-4101-99A0-6025CFD60D63}"/>
+                <a16:creationId xmlns:a16="http://schemas.microsoft.com/office/drawing/2014/main" id="{23006CB8-5F07-44F9-814C-830026E693CE}"/>
               </a:ext>
             </a:extLst>
           </p:cNvPr>
@@ -10408,7 +10442,7 @@
     </p:spTree>
     <p:extLst>
       <p:ext uri="{BB962C8B-B14F-4D97-AF65-F5344CB8AC3E}">
-        <p14:creationId xmlns:p14="http://schemas.microsoft.com/office/powerpoint/2010/main" val="217634554"/>
+        <p14:creationId xmlns:p14="http://schemas.microsoft.com/office/powerpoint/2010/main" val="1703507043"/>
       </p:ext>
     </p:extLst>
   </p:cSld>
@@ -10416,7 +10450,7 @@
 </file>
 
 <file path=ppt/slides/slide9.xml><?xml version="1.0" encoding="utf-8"?>
-<p:sld xmlns:p="http://schemas.openxmlformats.org/presentationml/2006/main" showMasterSp="0">
+<p:sld xmlns:p="http://schemas.openxmlformats.org/presentationml/2006/main">
   <p:cSld>
     <p:spTree>
       <p:nvGrpSpPr>
@@ -10432,7 +10466,7 @@
           <p:cNvPr id="6" name="">
             <a:extLst xmlns:a="http://schemas.openxmlformats.org/drawingml/2006/main">
               <a:ext uri="{FF2B5EF4-FFF2-40B4-BE49-F238E27FC236}">
-                <a16:creationId xmlns:a16="http://schemas.microsoft.com/office/drawing/2014/main" id="{AAE2BB3C-A01C-4AFD-87CD-227F4BB69335}"/>
+                <a16:creationId xmlns:a16="http://schemas.microsoft.com/office/drawing/2014/main" id="{F6E8AAC8-94F1-4F53-B7F9-9357469ED75B}"/>
               </a:ext>
             </a:extLst>
           </p:cNvPr>
@@ -10465,7 +10499,7 @@
           <p:cNvPr id="2" name="">
             <a:extLst xmlns:a="http://schemas.openxmlformats.org/drawingml/2006/main">
               <a:ext uri="{FF2B5EF4-FFF2-40B4-BE49-F238E27FC236}">
-                <a16:creationId xmlns:a16="http://schemas.microsoft.com/office/drawing/2014/main" id="{9D67DB47-27A9-4B01-8DD8-26C42A4FBC4C}"/>
+                <a16:creationId xmlns:a16="http://schemas.microsoft.com/office/drawing/2014/main" id="{0DC3E352-3E16-4859-9F7A-EA3660550744}"/>
               </a:ext>
             </a:extLst>
           </p:cNvPr>
@@ -10505,7 +10539,7 @@
                   <a:srgbClr val="065CAB"/>
                 </a:solidFill>
               </a:rPr>
-              <a:t>Test: модуль упругости</a:t>
+              <a:t>Отложенная оценка: модуль</a:t>
             </a:r>
           </a:p>
         </p:txBody>
@@ -10515,7 +10549,7 @@
           <p:cNvPr id="3" name="">
             <a:extLst xmlns:a="http://schemas.openxmlformats.org/drawingml/2006/main">
               <a:ext uri="{FF2B5EF4-FFF2-40B4-BE49-F238E27FC236}">
-                <a16:creationId xmlns:a16="http://schemas.microsoft.com/office/drawing/2014/main" id="{165B4B7A-B477-4BBD-962D-47DF4799707F}"/>
+                <a16:creationId xmlns:a16="http://schemas.microsoft.com/office/drawing/2014/main" id="{6094249F-0171-4761-940A-4A53459D2596}"/>
               </a:ext>
             </a:extLst>
           </p:cNvPr>
@@ -10555,7 +10589,7 @@
                   <a:srgbClr val="262626"/>
                 </a:solidFill>
               </a:rPr>
-              <a:t>• Выбран baseline</a:t>
+              <a:t>• Выбрана константная модель</a:t>
             </a:r>
           </a:p>
           <a:p xmlns:a="http://schemas.openxmlformats.org/drawingml/2006/main">
@@ -10623,7 +10657,7 @@
                   <a:srgbClr val="262626"/>
                 </a:solidFill>
               </a:rPr>
-              <a:t>• Сложные модели не улучшили baseline</a:t>
+              <a:t>• Испытанные модели не снизили среднюю CV RMSE</a:t>
             </a:r>
           </a:p>
         </p:txBody>
@@ -10637,7 +10671,7 @@
           <p:nvPr/>
         </p:nvPicPr>
         <p:blipFill>
-          <a:blip xmlns:r="http://schemas.openxmlformats.org/officeDocument/2006/relationships" xmlns:a="http://schemas.openxmlformats.org/drawingml/2006/main" r:embed="Rfd78d8a1971e4e4a"/>
+          <a:blip xmlns:r="http://schemas.openxmlformats.org/officeDocument/2006/relationships" xmlns:a="http://schemas.openxmlformats.org/drawingml/2006/main" r:embed="R2444a844dcbb46ba"/>
           <a:stretch xmlns:a="http://schemas.openxmlformats.org/drawingml/2006/main"/>
         </p:blipFill>
         <p:spPr>
@@ -10655,7 +10689,7 @@
           <p:cNvPr id="5" name="">
             <a:extLst xmlns:a="http://schemas.openxmlformats.org/drawingml/2006/main">
               <a:ext uri="{FF2B5EF4-FFF2-40B4-BE49-F238E27FC236}">
-                <a16:creationId xmlns:a16="http://schemas.microsoft.com/office/drawing/2014/main" id="{AED835F6-4DAD-45FC-B7F4-082EBAA63926}"/>
+                <a16:creationId xmlns:a16="http://schemas.microsoft.com/office/drawing/2014/main" id="{B492DC4B-2291-4ACA-B0A5-1D185D1C4A7C}"/>
               </a:ext>
             </a:extLst>
           </p:cNvPr>
@@ -10703,7 +10737,7 @@
     </p:spTree>
     <p:extLst>
       <p:ext uri="{BB962C8B-B14F-4D97-AF65-F5344CB8AC3E}">
-        <p14:creationId xmlns:p14="http://schemas.microsoft.com/office/powerpoint/2010/main" val="217634554"/>
+        <p14:creationId xmlns:p14="http://schemas.microsoft.com/office/powerpoint/2010/main" val="1703507043"/>
       </p:ext>
     </p:extLst>
   </p:cSld>

</xml_diff>